<commit_message>
case studies (hotel, rider, Oslo winter, running clubs), run mode; placeholders replaced with sources
</commit_message>
<xml_diff>
--- a/docs/pitch/Zill-and-Shams-pitch.pptx
+++ b/docs/pitch/Zill-and-Shams-pitch.pptx
@@ -798,7 +798,7 @@
           <a:lstStyle/>
           <a:p>
             <a:r>
-              <a:t>Who pays. Target customers (not partners): Talabat, Deliveroo, Careem. Expanded scope: city planners (B2G planning analytics: where to plant trees or add shade), schools, elderly care, events, real estate. Prices are hypotheses; none quoted.</a:t>
+              <a:t>Who pays. Target customers (not partners): Talabat, Deliveroo, Careem. Expanded scope: city planners (B2G planning analytics: where to plant trees or add shade), schools, elderly care, events, real estate. Pricing hypotheses (not validated): hotels ~$99 per property per month; fleets ~$1 per rider per month; outdoor employers ~$49 per site per month; city licence ~$15,000 per year; corporate well-being ~$12 per employee per year; consumer premium ~$2.99 per month, no ads.</a:t>
             </a:r>
           </a:p>
         </p:txBody>
@@ -938,7 +938,7 @@
           <a:lstStyle/>
           <a:p>
             <a:r>
-              <a:t>Costs (docs/COSTS.md). Contabo price and per-1,000-user cost are [TEAM TO FILL]. OpenCode Go $10/month flat: ~3,630 conversations on glm-5.3-flash, ~56 on kimi-k3 (page request estimates, 8.7 requests per conversation measured). Bake timings on a dev laptop, not the VM.</a:t>
+              <a:t>Costs (docs/COSTS.md). Server $6.93/month (Contabo VPS, 4 vCPU, 8 GB); per 1,000 users about $0.002 of server; fixed cost about $17/month. OpenCode Go $10/month flat: ~3,630 conversations on glm-5.3-flash, ~56 on kimi-k3 (page request estimates, 8.7 requests per conversation measured). Bake timings on a dev laptop, not the VM.</a:t>
             </a:r>
           </a:p>
         </p:txBody>
@@ -1008,7 +1008,7 @@
           <a:lstStyle/>
           <a:p>
             <a:r>
-              <a:t>Users. Market: 70,000+ riders, 18.72 M visitors (sourced; context, not a forecast). Capacity measured with scripts/loadtest.py: local machine peaks ~26 req/s at 20 users (p95 596 ms), 40 users p95 2.6 s; live VM at 20 users 16.9 req/s, p95 1.6 s, 0 errors (run capped at 20 users, did not saturate). VM CPU count [TEAM TO FILL].</a:t>
+              <a:t>Users. Market: 70,000+ riders, 18.72 M visitors (sourced; context, not a forecast). Capacity measured with scripts/loadtest.py: local machine peaks ~26 req/s at 20 users (p95 596 ms), 40 users p95 2.6 s; live VM at 20 users 16.9 req/s, p95 1.6 s, 0 errors (run capped at 20 users, did not saturate). VM: 4 vCPU, 8 GB.</a:t>
             </a:r>
           </a:p>
         </p:txBody>
@@ -9836,7 +9836,7 @@
         <p:spPr>
           <a:xfrm>
             <a:off x="3982641" y="1919585"/>
-            <a:ext cx="5668070" cy="6350"/>
+            <a:ext cx="5655866" cy="6350"/>
           </a:xfrm>
           <a:prstGeom prst="rect">
             <a:avLst/>
@@ -9881,8 +9881,8 @@
         </p:nvSpPr>
         <p:spPr>
           <a:xfrm>
-            <a:off x="9650710" y="1919585"/>
-            <a:ext cx="1728490" cy="6350"/>
+            <a:off x="9638506" y="1919585"/>
+            <a:ext cx="1740694" cy="6350"/>
           </a:xfrm>
           <a:prstGeom prst="rect">
             <a:avLst/>
@@ -9974,7 +9974,7 @@
         <p:spPr>
           <a:xfrm>
             <a:off x="3982641" y="2555180"/>
-            <a:ext cx="5668070" cy="6350"/>
+            <a:ext cx="5655866" cy="6350"/>
           </a:xfrm>
           <a:prstGeom prst="rect">
             <a:avLst/>
@@ -10019,8 +10019,8 @@
         </p:nvSpPr>
         <p:spPr>
           <a:xfrm>
-            <a:off x="9650710" y="2555180"/>
-            <a:ext cx="1728490" cy="6350"/>
+            <a:off x="9638506" y="2555180"/>
+            <a:ext cx="1740694" cy="6350"/>
           </a:xfrm>
           <a:prstGeom prst="rect">
             <a:avLst/>
@@ -10065,7 +10065,7 @@
         </p:nvSpPr>
         <p:spPr>
           <a:xfrm>
-            <a:off x="812800" y="3033316"/>
+            <a:off x="812800" y="3289796"/>
             <a:ext cx="3169841" cy="6350"/>
           </a:xfrm>
           <a:prstGeom prst="rect">
@@ -10111,8 +10111,8 @@
         </p:nvSpPr>
         <p:spPr>
           <a:xfrm>
-            <a:off x="3982641" y="3033316"/>
-            <a:ext cx="5668070" cy="6350"/>
+            <a:off x="3982641" y="3289796"/>
+            <a:ext cx="5655866" cy="6350"/>
           </a:xfrm>
           <a:prstGeom prst="rect">
             <a:avLst/>
@@ -10157,8 +10157,8 @@
         </p:nvSpPr>
         <p:spPr>
           <a:xfrm>
-            <a:off x="9650710" y="3033316"/>
-            <a:ext cx="1728490" cy="6350"/>
+            <a:off x="9638506" y="3289796"/>
+            <a:ext cx="1740694" cy="6350"/>
           </a:xfrm>
           <a:prstGeom prst="rect">
             <a:avLst/>
@@ -10203,7 +10203,7 @@
         </p:nvSpPr>
         <p:spPr>
           <a:xfrm>
-            <a:off x="812800" y="3511451"/>
+            <a:off x="812800" y="3892352"/>
             <a:ext cx="3169841" cy="6350"/>
           </a:xfrm>
           <a:prstGeom prst="rect">
@@ -10249,8 +10249,8 @@
         </p:nvSpPr>
         <p:spPr>
           <a:xfrm>
-            <a:off x="3982641" y="3511451"/>
-            <a:ext cx="5668070" cy="6350"/>
+            <a:off x="3982641" y="3892352"/>
+            <a:ext cx="5655866" cy="6350"/>
           </a:xfrm>
           <a:prstGeom prst="rect">
             <a:avLst/>
@@ -10295,8 +10295,8 @@
         </p:nvSpPr>
         <p:spPr>
           <a:xfrm>
-            <a:off x="9650710" y="3511451"/>
-            <a:ext cx="1728490" cy="6350"/>
+            <a:off x="9638506" y="3892352"/>
+            <a:ext cx="1740694" cy="6350"/>
           </a:xfrm>
           <a:prstGeom prst="rect">
             <a:avLst/>
@@ -10341,7 +10341,7 @@
         </p:nvSpPr>
         <p:spPr>
           <a:xfrm>
-            <a:off x="812800" y="4147046"/>
+            <a:off x="812800" y="4626967"/>
             <a:ext cx="3169841" cy="6350"/>
           </a:xfrm>
           <a:prstGeom prst="rect">
@@ -10387,8 +10387,8 @@
         </p:nvSpPr>
         <p:spPr>
           <a:xfrm>
-            <a:off x="3982641" y="4147046"/>
-            <a:ext cx="5668070" cy="6350"/>
+            <a:off x="3982641" y="4626967"/>
+            <a:ext cx="5655866" cy="6350"/>
           </a:xfrm>
           <a:prstGeom prst="rect">
             <a:avLst/>
@@ -10433,8 +10433,8 @@
         </p:nvSpPr>
         <p:spPr>
           <a:xfrm>
-            <a:off x="9650710" y="4147046"/>
-            <a:ext cx="1728490" cy="6350"/>
+            <a:off x="9638506" y="4626967"/>
+            <a:ext cx="1740694" cy="6350"/>
           </a:xfrm>
           <a:prstGeom prst="rect">
             <a:avLst/>
@@ -10479,7 +10479,7 @@
         </p:nvSpPr>
         <p:spPr>
           <a:xfrm>
-            <a:off x="812800" y="4881066"/>
+            <a:off x="812800" y="5360988"/>
             <a:ext cx="3169841" cy="6350"/>
           </a:xfrm>
           <a:prstGeom prst="rect">
@@ -10525,8 +10525,8 @@
         </p:nvSpPr>
         <p:spPr>
           <a:xfrm>
-            <a:off x="3982641" y="4881066"/>
-            <a:ext cx="5668070" cy="6350"/>
+            <a:off x="3982641" y="5360988"/>
+            <a:ext cx="5655866" cy="6350"/>
           </a:xfrm>
           <a:prstGeom prst="rect">
             <a:avLst/>
@@ -10571,8 +10571,8 @@
         </p:nvSpPr>
         <p:spPr>
           <a:xfrm>
-            <a:off x="9650710" y="4881066"/>
-            <a:ext cx="1728490" cy="6350"/>
+            <a:off x="9638506" y="5360988"/>
+            <a:ext cx="1740694" cy="6350"/>
           </a:xfrm>
           <a:prstGeom prst="rect">
             <a:avLst/>
@@ -10617,7 +10617,7 @@
         </p:nvSpPr>
         <p:spPr>
           <a:xfrm>
-            <a:off x="812800" y="5615087"/>
+            <a:off x="812800" y="6186388"/>
             <a:ext cx="3169841" cy="6350"/>
           </a:xfrm>
           <a:prstGeom prst="rect">
@@ -10663,8 +10663,8 @@
         </p:nvSpPr>
         <p:spPr>
           <a:xfrm>
-            <a:off x="3982641" y="5615087"/>
-            <a:ext cx="5668070" cy="6350"/>
+            <a:off x="3982641" y="6186388"/>
+            <a:ext cx="5655866" cy="6350"/>
           </a:xfrm>
           <a:prstGeom prst="rect">
             <a:avLst/>
@@ -10709,8 +10709,8 @@
         </p:nvSpPr>
         <p:spPr>
           <a:xfrm>
-            <a:off x="9650710" y="5615087"/>
-            <a:ext cx="1728490" cy="6350"/>
+            <a:off x="9638506" y="6186388"/>
+            <a:ext cx="1740694" cy="6350"/>
           </a:xfrm>
           <a:prstGeom prst="rect">
             <a:avLst/>
@@ -10919,7 +10919,7 @@
         <p:spPr>
           <a:xfrm>
             <a:off x="3982641" y="1694160"/>
-            <a:ext cx="5515670" cy="130175"/>
+            <a:ext cx="5503466" cy="130175"/>
           </a:xfrm>
           <a:prstGeom prst="rect">
             <a:avLst/>
@@ -10957,8 +10957,8 @@
         </p:nvSpPr>
         <p:spPr>
           <a:xfrm>
-            <a:off x="9650710" y="1694160"/>
-            <a:ext cx="1576090" cy="130175"/>
+            <a:off x="9638506" y="1694160"/>
+            <a:ext cx="1588294" cy="130175"/>
           </a:xfrm>
           <a:prstGeom prst="rect">
             <a:avLst/>
@@ -11077,7 +11077,7 @@
         <p:spPr>
           <a:xfrm>
             <a:off x="3982641" y="2033885"/>
-            <a:ext cx="5654978" cy="419695"/>
+            <a:ext cx="5642408" cy="419695"/>
           </a:xfrm>
           <a:prstGeom prst="rect">
             <a:avLst/>
@@ -11115,16 +11115,16 @@
         </p:nvSpPr>
         <p:spPr>
           <a:xfrm>
-            <a:off x="9650710" y="2033885"/>
-            <a:ext cx="1597211" cy="419695"/>
-          </a:xfrm>
-          <a:prstGeom prst="rect">
-            <a:avLst/>
-          </a:prstGeom>
-          <a:noFill/>
-        </p:spPr>
-        <p:txBody>
-          <a:bodyPr wrap="square" lIns="0" rIns="0" tIns="0" bIns="0" anchor="t">
+            <a:off x="9638506" y="2043410"/>
+            <a:ext cx="1486694" cy="209550"/>
+          </a:xfrm>
+          <a:prstGeom prst="rect">
+            <a:avLst/>
+          </a:prstGeom>
+          <a:noFill/>
+        </p:spPr>
+        <p:txBody>
+          <a:bodyPr wrap="none" lIns="0" rIns="0" tIns="0" bIns="0" anchor="t">
             <a:spAutoFit/>
           </a:bodyPr>
           <a:lstStyle/>
@@ -11154,281 +11154,8 @@
         </p:nvSpPr>
         <p:spPr>
           <a:xfrm>
-            <a:off x="812800" y="2669480"/>
-            <a:ext cx="2992041" cy="262235"/>
-          </a:xfrm>
-          <a:prstGeom prst="rect">
-            <a:avLst/>
-          </a:prstGeom>
-          <a:noFill/>
-        </p:spPr>
-        <p:txBody>
-          <a:bodyPr wrap="none" lIns="0" rIns="0" tIns="0" bIns="0" anchor="t">
-            <a:spAutoFit/>
-          </a:bodyPr>
-          <a:lstStyle/>
-          <a:p>
-            <a:pPr algn="l">
-              <a:lnSpc>
-                <a:spcPts val="1954"/>
-              </a:lnSpc>
-            </a:pPr>
-            <a:r>
-              <a:rPr sz="1441" b="0" i="0">
-                <a:solidFill>
-                  <a:srgbClr val="E9DCBC"/>
-                </a:solidFill>
-                <a:latin typeface="Georgia"/>
-              </a:rPr>
-              <a:t>Hotels and tourism boards</a:t>
-            </a:r>
-          </a:p>
-        </p:txBody>
-      </p:sp>
-      <p:sp>
-        <p:nvSpPr>
-          <p:cNvPr id="34" name="TextBox 33"/>
-          <p:cNvSpPr txBox="1"/>
-          <p:nvPr/>
-        </p:nvSpPr>
-        <p:spPr>
-          <a:xfrm>
-            <a:off x="3982641" y="2669480"/>
-            <a:ext cx="5490270" cy="262235"/>
-          </a:xfrm>
-          <a:prstGeom prst="rect">
-            <a:avLst/>
-          </a:prstGeom>
-          <a:noFill/>
-        </p:spPr>
-        <p:txBody>
-          <a:bodyPr wrap="none" lIns="0" rIns="0" tIns="0" bIns="0" anchor="t">
-            <a:spAutoFit/>
-          </a:bodyPr>
-          <a:lstStyle/>
-          <a:p>
-            <a:pPr algn="l">
-              <a:lnSpc>
-                <a:spcPts val="1702"/>
-              </a:lnSpc>
-            </a:pPr>
-            <a:r>
-              <a:rPr sz="1309" b="0" i="0">
-                <a:solidFill>
-                  <a:srgbClr val="F4EEE1"/>
-                </a:solidFill>
-                <a:latin typeface="Calibri"/>
-              </a:rPr>
-              <a:t>“Walk there in the shade, or in the sun” guest concierge</a:t>
-            </a:r>
-          </a:p>
-        </p:txBody>
-      </p:sp>
-      <p:sp>
-        <p:nvSpPr>
-          <p:cNvPr id="35" name="TextBox 34"/>
-          <p:cNvSpPr txBox="1"/>
-          <p:nvPr/>
-        </p:nvSpPr>
-        <p:spPr>
-          <a:xfrm>
-            <a:off x="9650710" y="2669480"/>
-            <a:ext cx="1550690" cy="262235"/>
-          </a:xfrm>
-          <a:prstGeom prst="rect">
-            <a:avLst/>
-          </a:prstGeom>
-          <a:noFill/>
-        </p:spPr>
-        <p:txBody>
-          <a:bodyPr wrap="none" lIns="0" rIns="0" tIns="0" bIns="0" anchor="t">
-            <a:spAutoFit/>
-          </a:bodyPr>
-          <a:lstStyle/>
-          <a:p>
-            <a:pPr algn="l">
-              <a:lnSpc>
-                <a:spcPts val="1702"/>
-              </a:lnSpc>
-            </a:pPr>
-            <a:r>
-              <a:rPr sz="1309" b="0" i="0">
-                <a:solidFill>
-                  <a:srgbClr val="C8A15A"/>
-                </a:solidFill>
-                <a:latin typeface="Calibri"/>
-              </a:rPr>
-              <a:t>Per hotel per month</a:t>
-            </a:r>
-          </a:p>
-        </p:txBody>
-      </p:sp>
-      <p:sp>
-        <p:nvSpPr>
-          <p:cNvPr id="36" name="TextBox 35"/>
-          <p:cNvSpPr txBox="1"/>
-          <p:nvPr/>
-        </p:nvSpPr>
-        <p:spPr>
-          <a:xfrm>
-            <a:off x="812800" y="3147616"/>
-            <a:ext cx="2992041" cy="262235"/>
-          </a:xfrm>
-          <a:prstGeom prst="rect">
-            <a:avLst/>
-          </a:prstGeom>
-          <a:noFill/>
-        </p:spPr>
-        <p:txBody>
-          <a:bodyPr wrap="none" lIns="0" rIns="0" tIns="0" bIns="0" anchor="t">
-            <a:spAutoFit/>
-          </a:bodyPr>
-          <a:lstStyle/>
-          <a:p>
-            <a:pPr algn="l">
-              <a:lnSpc>
-                <a:spcPts val="1954"/>
-              </a:lnSpc>
-            </a:pPr>
-            <a:r>
-              <a:rPr sz="1441" b="0" i="0">
-                <a:solidFill>
-                  <a:srgbClr val="E9DCBC"/>
-                </a:solidFill>
-                <a:latin typeface="Georgia"/>
-              </a:rPr>
-              <a:t>Employers of outdoor workers</a:t>
-            </a:r>
-          </a:p>
-        </p:txBody>
-      </p:sp>
-      <p:sp>
-        <p:nvSpPr>
-          <p:cNvPr id="37" name="TextBox 36"/>
-          <p:cNvSpPr txBox="1"/>
-          <p:nvPr/>
-        </p:nvSpPr>
-        <p:spPr>
-          <a:xfrm>
-            <a:off x="3982641" y="3147616"/>
-            <a:ext cx="5490270" cy="262235"/>
-          </a:xfrm>
-          <a:prstGeom prst="rect">
-            <a:avLst/>
-          </a:prstGeom>
-          <a:noFill/>
-        </p:spPr>
-        <p:txBody>
-          <a:bodyPr wrap="none" lIns="0" rIns="0" tIns="0" bIns="0" anchor="t">
-            <a:spAutoFit/>
-          </a:bodyPr>
-          <a:lstStyle/>
-          <a:p>
-            <a:pPr algn="l">
-              <a:lnSpc>
-                <a:spcPts val="1702"/>
-              </a:lnSpc>
-            </a:pPr>
-            <a:r>
-              <a:rPr sz="1309" b="0" i="0">
-                <a:solidFill>
-                  <a:srgbClr val="F4EEE1"/>
-                </a:solidFill>
-                <a:latin typeface="Calibri"/>
-              </a:rPr>
-              <a:t>Shift planner that respects the midday break</a:t>
-            </a:r>
-          </a:p>
-        </p:txBody>
-      </p:sp>
-      <p:sp>
-        <p:nvSpPr>
-          <p:cNvPr id="38" name="TextBox 37"/>
-          <p:cNvSpPr txBox="1"/>
-          <p:nvPr/>
-        </p:nvSpPr>
-        <p:spPr>
-          <a:xfrm>
-            <a:off x="9650710" y="3147616"/>
-            <a:ext cx="1550690" cy="262235"/>
-          </a:xfrm>
-          <a:prstGeom prst="rect">
-            <a:avLst/>
-          </a:prstGeom>
-          <a:noFill/>
-        </p:spPr>
-        <p:txBody>
-          <a:bodyPr wrap="none" lIns="0" rIns="0" tIns="0" bIns="0" anchor="t">
-            <a:spAutoFit/>
-          </a:bodyPr>
-          <a:lstStyle/>
-          <a:p>
-            <a:pPr algn="l">
-              <a:lnSpc>
-                <a:spcPts val="1702"/>
-              </a:lnSpc>
-            </a:pPr>
-            <a:r>
-              <a:rPr sz="1309" b="0" i="0">
-                <a:solidFill>
-                  <a:srgbClr val="C8A15A"/>
-                </a:solidFill>
-                <a:latin typeface="Calibri"/>
-              </a:rPr>
-              <a:t>Per site per month</a:t>
-            </a:r>
-          </a:p>
-        </p:txBody>
-      </p:sp>
-      <p:sp>
-        <p:nvSpPr>
-          <p:cNvPr id="39" name="TextBox 38"/>
-          <p:cNvSpPr txBox="1"/>
-          <p:nvPr/>
-        </p:nvSpPr>
-        <p:spPr>
-          <a:xfrm>
-            <a:off x="812800" y="3635276"/>
-            <a:ext cx="2915841" cy="241300"/>
-          </a:xfrm>
-          <a:prstGeom prst="rect">
-            <a:avLst/>
-          </a:prstGeom>
-          <a:noFill/>
-        </p:spPr>
-        <p:txBody>
-          <a:bodyPr wrap="none" lIns="0" rIns="0" tIns="0" bIns="0" anchor="t">
-            <a:spAutoFit/>
-          </a:bodyPr>
-          <a:lstStyle/>
-          <a:p>
-            <a:pPr algn="l">
-              <a:lnSpc>
-                <a:spcPts val="1954"/>
-              </a:lnSpc>
-            </a:pPr>
-            <a:r>
-              <a:rPr sz="1441" b="0" i="0">
-                <a:solidFill>
-                  <a:srgbClr val="E9DCBC"/>
-                </a:solidFill>
-                <a:latin typeface="Georgia"/>
-              </a:rPr>
-              <a:t>Cities and city planners</a:t>
-            </a:r>
-          </a:p>
-        </p:txBody>
-      </p:sp>
-      <p:sp>
-        <p:nvSpPr>
-          <p:cNvPr id="40" name="TextBox 39"/>
-          <p:cNvSpPr txBox="1"/>
-          <p:nvPr/>
-        </p:nvSpPr>
-        <p:spPr>
-          <a:xfrm>
-            <a:off x="812800" y="3910211"/>
-            <a:ext cx="2992041" cy="132060"/>
+            <a:off x="9638506" y="2285305"/>
+            <a:ext cx="1562894" cy="132060"/>
           </a:xfrm>
           <a:prstGeom prst="rect">
             <a:avLst/>
@@ -11455,21 +11182,21 @@
                 </a:solidFill>
                 <a:latin typeface="Calibri"/>
               </a:rPr>
-              <a:t>B2G planning analytics</a:t>
-            </a:r>
-          </a:p>
-        </p:txBody>
-      </p:sp>
-      <p:sp>
-        <p:nvSpPr>
-          <p:cNvPr id="41" name="TextBox 40"/>
-          <p:cNvSpPr txBox="1"/>
-          <p:nvPr/>
-        </p:nvSpPr>
-        <p:spPr>
-          <a:xfrm>
-            <a:off x="3982641" y="3625751"/>
-            <a:ext cx="5654978" cy="419695"/>
+              <a:t>pricing hypothesis: ~$1</a:t>
+            </a:r>
+          </a:p>
+        </p:txBody>
+      </p:sp>
+      <p:sp>
+        <p:nvSpPr>
+          <p:cNvPr id="34" name="TextBox 33"/>
+          <p:cNvSpPr txBox="1"/>
+          <p:nvPr/>
+        </p:nvSpPr>
+        <p:spPr>
+          <a:xfrm>
+            <a:off x="812800" y="2669480"/>
+            <a:ext cx="3081802" cy="518716"/>
           </a:xfrm>
           <a:prstGeom prst="rect">
             <a:avLst/>
@@ -11484,6 +11211,45 @@
           <a:p>
             <a:pPr algn="l">
               <a:lnSpc>
+                <a:spcPts val="1954"/>
+              </a:lnSpc>
+            </a:pPr>
+            <a:r>
+              <a:rPr sz="1441" b="0" i="0">
+                <a:solidFill>
+                  <a:srgbClr val="E9DCBC"/>
+                </a:solidFill>
+                <a:latin typeface="Georgia"/>
+              </a:rPr>
+              <a:t>Hotels and tourism boards</a:t>
+            </a:r>
+          </a:p>
+        </p:txBody>
+      </p:sp>
+      <p:sp>
+        <p:nvSpPr>
+          <p:cNvPr id="35" name="TextBox 34"/>
+          <p:cNvSpPr txBox="1"/>
+          <p:nvPr/>
+        </p:nvSpPr>
+        <p:spPr>
+          <a:xfrm>
+            <a:off x="3982641" y="2669480"/>
+            <a:ext cx="5642408" cy="518716"/>
+          </a:xfrm>
+          <a:prstGeom prst="rect">
+            <a:avLst/>
+          </a:prstGeom>
+          <a:noFill/>
+        </p:spPr>
+        <p:txBody>
+          <a:bodyPr wrap="square" lIns="0" rIns="0" tIns="0" bIns="0" anchor="t">
+            <a:spAutoFit/>
+          </a:bodyPr>
+          <a:lstStyle/>
+          <a:p>
+            <a:pPr algn="l">
+              <a:lnSpc>
                 <a:spcPts val="1702"/>
               </a:lnSpc>
             </a:pPr>
@@ -11494,21 +11260,60 @@
                 </a:solidFill>
                 <a:latin typeface="Calibri"/>
               </a:rPr>
-              <a:t>Where to plant trees or add shade, from the same engine</a:t>
-            </a:r>
-          </a:p>
-        </p:txBody>
-      </p:sp>
-      <p:sp>
-        <p:nvSpPr>
-          <p:cNvPr id="42" name="TextBox 41"/>
-          <p:cNvSpPr txBox="1"/>
-          <p:nvPr/>
-        </p:nvSpPr>
-        <p:spPr>
-          <a:xfrm>
-            <a:off x="9650710" y="3625751"/>
-            <a:ext cx="1597211" cy="419695"/>
+              <a:t>“Walk there in the shade, or in the sun” guest concierge</a:t>
+            </a:r>
+          </a:p>
+        </p:txBody>
+      </p:sp>
+      <p:sp>
+        <p:nvSpPr>
+          <p:cNvPr id="36" name="TextBox 35"/>
+          <p:cNvSpPr txBox="1"/>
+          <p:nvPr/>
+        </p:nvSpPr>
+        <p:spPr>
+          <a:xfrm>
+            <a:off x="9638506" y="2679005"/>
+            <a:ext cx="1486694" cy="209550"/>
+          </a:xfrm>
+          <a:prstGeom prst="rect">
+            <a:avLst/>
+          </a:prstGeom>
+          <a:noFill/>
+        </p:spPr>
+        <p:txBody>
+          <a:bodyPr wrap="none" lIns="0" rIns="0" tIns="0" bIns="0" anchor="t">
+            <a:spAutoFit/>
+          </a:bodyPr>
+          <a:lstStyle/>
+          <a:p>
+            <a:pPr algn="l">
+              <a:lnSpc>
+                <a:spcPts val="1702"/>
+              </a:lnSpc>
+            </a:pPr>
+            <a:r>
+              <a:rPr sz="1309" b="0" i="0">
+                <a:solidFill>
+                  <a:srgbClr val="C8A15A"/>
+                </a:solidFill>
+                <a:latin typeface="Calibri"/>
+              </a:rPr>
+              <a:t>Per hotel per month</a:t>
+            </a:r>
+          </a:p>
+        </p:txBody>
+      </p:sp>
+      <p:sp>
+        <p:nvSpPr>
+          <p:cNvPr id="37" name="TextBox 36"/>
+          <p:cNvSpPr txBox="1"/>
+          <p:nvPr/>
+        </p:nvSpPr>
+        <p:spPr>
+          <a:xfrm>
+            <a:off x="9638506" y="2920901"/>
+            <a:ext cx="1609781" cy="264120"/>
           </a:xfrm>
           <a:prstGeom prst="rect">
             <a:avLst/>
@@ -11523,284 +11328,11 @@
           <a:p>
             <a:pPr algn="l">
               <a:lnSpc>
-                <a:spcPts val="1702"/>
-              </a:lnSpc>
-            </a:pPr>
-            <a:r>
-              <a:rPr sz="1309" b="0" i="0">
-                <a:solidFill>
-                  <a:srgbClr val="C8A15A"/>
-                </a:solidFill>
-                <a:latin typeface="Calibri"/>
-              </a:rPr>
-              <a:t>City licence</a:t>
-            </a:r>
-          </a:p>
-        </p:txBody>
-      </p:sp>
-      <p:sp>
-        <p:nvSpPr>
-          <p:cNvPr id="43" name="TextBox 42"/>
-          <p:cNvSpPr txBox="1"/>
-          <p:nvPr/>
-        </p:nvSpPr>
-        <p:spPr>
-          <a:xfrm>
-            <a:off x="812800" y="4261346"/>
-            <a:ext cx="3081802" cy="518120"/>
-          </a:xfrm>
-          <a:prstGeom prst="rect">
-            <a:avLst/>
-          </a:prstGeom>
-          <a:noFill/>
-        </p:spPr>
-        <p:txBody>
-          <a:bodyPr wrap="square" lIns="0" rIns="0" tIns="0" bIns="0" anchor="t">
-            <a:spAutoFit/>
-          </a:bodyPr>
-          <a:lstStyle/>
-          <a:p>
-            <a:pPr algn="l">
-              <a:lnSpc>
-                <a:spcPts val="1954"/>
-              </a:lnSpc>
-            </a:pPr>
-            <a:r>
-              <a:rPr sz="1441" b="0" i="0">
-                <a:solidFill>
-                  <a:srgbClr val="E9DCBC"/>
-                </a:solidFill>
-                <a:latin typeface="Georgia"/>
-              </a:rPr>
-              <a:t>Schools, elderly care, events, real estate</a:t>
-            </a:r>
-          </a:p>
-        </p:txBody>
-      </p:sp>
-      <p:sp>
-        <p:nvSpPr>
-          <p:cNvPr id="44" name="TextBox 43"/>
-          <p:cNvSpPr txBox="1"/>
-          <p:nvPr/>
-        </p:nvSpPr>
-        <p:spPr>
-          <a:xfrm>
-            <a:off x="3982641" y="4261346"/>
-            <a:ext cx="5654978" cy="518120"/>
-          </a:xfrm>
-          <a:prstGeom prst="rect">
-            <a:avLst/>
-          </a:prstGeom>
-          <a:noFill/>
-        </p:spPr>
-        <p:txBody>
-          <a:bodyPr wrap="square" lIns="0" rIns="0" tIns="0" bIns="0" anchor="t">
-            <a:spAutoFit/>
-          </a:bodyPr>
-          <a:lstStyle/>
-          <a:p>
-            <a:pPr algn="l">
-              <a:lnSpc>
-                <a:spcPts val="1702"/>
-              </a:lnSpc>
-            </a:pPr>
-            <a:r>
-              <a:rPr sz="1309" b="0" i="0">
-                <a:solidFill>
-                  <a:srgbClr val="F4EEE1"/>
-                </a:solidFill>
-                <a:latin typeface="Calibri"/>
-              </a:rPr>
-              <a:t>Shaded routes and outdoor-time planning; shade and sun reports for sites and venues</a:t>
-            </a:r>
-          </a:p>
-        </p:txBody>
-      </p:sp>
-      <p:sp>
-        <p:nvSpPr>
-          <p:cNvPr id="45" name="TextBox 44"/>
-          <p:cNvSpPr txBox="1"/>
-          <p:nvPr/>
-        </p:nvSpPr>
-        <p:spPr>
-          <a:xfrm>
-            <a:off x="9650710" y="4261346"/>
-            <a:ext cx="1597211" cy="518120"/>
-          </a:xfrm>
-          <a:prstGeom prst="rect">
-            <a:avLst/>
-          </a:prstGeom>
-          <a:noFill/>
-        </p:spPr>
-        <p:txBody>
-          <a:bodyPr wrap="square" lIns="0" rIns="0" tIns="0" bIns="0" anchor="t">
-            <a:spAutoFit/>
-          </a:bodyPr>
-          <a:lstStyle/>
-          <a:p>
-            <a:pPr algn="l">
-              <a:lnSpc>
-                <a:spcPts val="1702"/>
-              </a:lnSpc>
-            </a:pPr>
-            <a:r>
-              <a:rPr sz="1309" b="0" i="0">
-                <a:solidFill>
-                  <a:srgbClr val="C8A15A"/>
-                </a:solidFill>
-                <a:latin typeface="Calibri"/>
-              </a:rPr>
-              <a:t>Per site subscription</a:t>
-            </a:r>
-          </a:p>
-        </p:txBody>
-      </p:sp>
-      <p:sp>
-        <p:nvSpPr>
-          <p:cNvPr id="46" name="TextBox 45"/>
-          <p:cNvSpPr txBox="1"/>
-          <p:nvPr/>
-        </p:nvSpPr>
-        <p:spPr>
-          <a:xfrm>
-            <a:off x="812800" y="4995366"/>
-            <a:ext cx="3081802" cy="518120"/>
-          </a:xfrm>
-          <a:prstGeom prst="rect">
-            <a:avLst/>
-          </a:prstGeom>
-          <a:noFill/>
-        </p:spPr>
-        <p:txBody>
-          <a:bodyPr wrap="square" lIns="0" rIns="0" tIns="0" bIns="0" anchor="t">
-            <a:spAutoFit/>
-          </a:bodyPr>
-          <a:lstStyle/>
-          <a:p>
-            <a:pPr algn="l">
-              <a:lnSpc>
-                <a:spcPts val="1954"/>
-              </a:lnSpc>
-            </a:pPr>
-            <a:r>
-              <a:rPr sz="1441" b="0" i="0">
-                <a:solidFill>
-                  <a:srgbClr val="E9DCBC"/>
-                </a:solidFill>
-                <a:latin typeface="Georgia"/>
-              </a:rPr>
-              <a:t>Corporate well-being and insurers</a:t>
-            </a:r>
-          </a:p>
-        </p:txBody>
-      </p:sp>
-      <p:sp>
-        <p:nvSpPr>
-          <p:cNvPr id="47" name="TextBox 46"/>
-          <p:cNvSpPr txBox="1"/>
-          <p:nvPr/>
-        </p:nvSpPr>
-        <p:spPr>
-          <a:xfrm>
-            <a:off x="3982641" y="4995366"/>
-            <a:ext cx="5654978" cy="518120"/>
-          </a:xfrm>
-          <a:prstGeom prst="rect">
-            <a:avLst/>
-          </a:prstGeom>
-          <a:noFill/>
-        </p:spPr>
-        <p:txBody>
-          <a:bodyPr wrap="square" lIns="0" rIns="0" tIns="0" bIns="0" anchor="t">
-            <a:spAutoFit/>
-          </a:bodyPr>
-          <a:lstStyle/>
-          <a:p>
-            <a:pPr algn="l">
-              <a:lnSpc>
-                <a:spcPts val="1702"/>
-              </a:lnSpc>
-            </a:pPr>
-            <a:r>
-              <a:rPr sz="1309" b="0" i="0">
-                <a:solidFill>
-                  <a:srgbClr val="F4EEE1"/>
-                </a:solidFill>
-                <a:latin typeface="Calibri"/>
-              </a:rPr>
-              <a:t>Daylight-walk programmes for staff</a:t>
-            </a:r>
-          </a:p>
-        </p:txBody>
-      </p:sp>
-      <p:sp>
-        <p:nvSpPr>
-          <p:cNvPr id="48" name="TextBox 47"/>
-          <p:cNvSpPr txBox="1"/>
-          <p:nvPr/>
-        </p:nvSpPr>
-        <p:spPr>
-          <a:xfrm>
-            <a:off x="9650710" y="4995366"/>
-            <a:ext cx="1597211" cy="518120"/>
-          </a:xfrm>
-          <a:prstGeom prst="rect">
-            <a:avLst/>
-          </a:prstGeom>
-          <a:noFill/>
-        </p:spPr>
-        <p:txBody>
-          <a:bodyPr wrap="square" lIns="0" rIns="0" tIns="0" bIns="0" anchor="t">
-            <a:spAutoFit/>
-          </a:bodyPr>
-          <a:lstStyle/>
-          <a:p>
-            <a:pPr algn="l">
-              <a:lnSpc>
-                <a:spcPts val="1702"/>
-              </a:lnSpc>
-            </a:pPr>
-            <a:r>
-              <a:rPr sz="1309" b="0" i="0">
-                <a:solidFill>
-                  <a:srgbClr val="C8A15A"/>
-                </a:solidFill>
-                <a:latin typeface="Calibri"/>
-              </a:rPr>
-              <a:t>Per employee per year</a:t>
-            </a:r>
-          </a:p>
-        </p:txBody>
-      </p:sp>
-      <p:sp>
-        <p:nvSpPr>
-          <p:cNvPr id="49" name="TextBox 48"/>
-          <p:cNvSpPr txBox="1"/>
-          <p:nvPr/>
-        </p:nvSpPr>
-        <p:spPr>
-          <a:xfrm>
-            <a:off x="812800" y="5738912"/>
-            <a:ext cx="10566400" cy="190500"/>
-          </a:xfrm>
-          <a:prstGeom prst="rect">
-            <a:avLst/>
-          </a:prstGeom>
-          <a:noFill/>
-        </p:spPr>
-        <p:txBody>
-          <a:bodyPr wrap="none" lIns="0" rIns="0" tIns="0" bIns="0" anchor="t">
-            <a:spAutoFit/>
-          </a:bodyPr>
-          <a:lstStyle/>
-          <a:p>
-            <a:pPr algn="l">
-              <a:lnSpc>
-                <a:spcPts val="1455"/>
-              </a:lnSpc>
-            </a:pPr>
-            <a:r>
-              <a:rPr sz="969" b="0" i="0">
+                <a:spcPts val="1008"/>
+              </a:lnSpc>
+            </a:pPr>
+            <a:r>
+              <a:rPr sz="776" b="0" i="0">
                 <a:solidFill>
                   <a:srgbClr val="F4EEE1">
                     <a:alpha val="62000"/>
@@ -11808,7 +11340,481 @@
                 </a:solidFill>
                 <a:latin typeface="Calibri"/>
               </a:rPr>
-              <a:t>Prices are hypotheses we are validating; none is quoted here.</a:t>
+              <a:t>pricing hypothesis: ~$99 per property</a:t>
+            </a:r>
+          </a:p>
+        </p:txBody>
+      </p:sp>
+      <p:sp>
+        <p:nvSpPr>
+          <p:cNvPr id="38" name="TextBox 37"/>
+          <p:cNvSpPr txBox="1"/>
+          <p:nvPr/>
+        </p:nvSpPr>
+        <p:spPr>
+          <a:xfrm>
+            <a:off x="812800" y="3404096"/>
+            <a:ext cx="3081802" cy="386655"/>
+          </a:xfrm>
+          <a:prstGeom prst="rect">
+            <a:avLst/>
+          </a:prstGeom>
+          <a:noFill/>
+        </p:spPr>
+        <p:txBody>
+          <a:bodyPr wrap="square" lIns="0" rIns="0" tIns="0" bIns="0" anchor="t">
+            <a:spAutoFit/>
+          </a:bodyPr>
+          <a:lstStyle/>
+          <a:p>
+            <a:pPr algn="l">
+              <a:lnSpc>
+                <a:spcPts val="1954"/>
+              </a:lnSpc>
+            </a:pPr>
+            <a:r>
+              <a:rPr sz="1441" b="0" i="0">
+                <a:solidFill>
+                  <a:srgbClr val="E9DCBC"/>
+                </a:solidFill>
+                <a:latin typeface="Georgia"/>
+              </a:rPr>
+              <a:t>Employers of outdoor workers</a:t>
+            </a:r>
+          </a:p>
+        </p:txBody>
+      </p:sp>
+      <p:sp>
+        <p:nvSpPr>
+          <p:cNvPr id="39" name="TextBox 38"/>
+          <p:cNvSpPr txBox="1"/>
+          <p:nvPr/>
+        </p:nvSpPr>
+        <p:spPr>
+          <a:xfrm>
+            <a:off x="3982641" y="3404096"/>
+            <a:ext cx="5642408" cy="386655"/>
+          </a:xfrm>
+          <a:prstGeom prst="rect">
+            <a:avLst/>
+          </a:prstGeom>
+          <a:noFill/>
+        </p:spPr>
+        <p:txBody>
+          <a:bodyPr wrap="square" lIns="0" rIns="0" tIns="0" bIns="0" anchor="t">
+            <a:spAutoFit/>
+          </a:bodyPr>
+          <a:lstStyle/>
+          <a:p>
+            <a:pPr algn="l">
+              <a:lnSpc>
+                <a:spcPts val="1702"/>
+              </a:lnSpc>
+            </a:pPr>
+            <a:r>
+              <a:rPr sz="1309" b="0" i="0">
+                <a:solidFill>
+                  <a:srgbClr val="F4EEE1"/>
+                </a:solidFill>
+                <a:latin typeface="Calibri"/>
+              </a:rPr>
+              <a:t>Shift planner that respects the midday break</a:t>
+            </a:r>
+          </a:p>
+        </p:txBody>
+      </p:sp>
+      <p:sp>
+        <p:nvSpPr>
+          <p:cNvPr id="40" name="TextBox 39"/>
+          <p:cNvSpPr txBox="1"/>
+          <p:nvPr/>
+        </p:nvSpPr>
+        <p:spPr>
+          <a:xfrm>
+            <a:off x="9638506" y="3413621"/>
+            <a:ext cx="1486694" cy="209550"/>
+          </a:xfrm>
+          <a:prstGeom prst="rect">
+            <a:avLst/>
+          </a:prstGeom>
+          <a:noFill/>
+        </p:spPr>
+        <p:txBody>
+          <a:bodyPr wrap="none" lIns="0" rIns="0" tIns="0" bIns="0" anchor="t">
+            <a:spAutoFit/>
+          </a:bodyPr>
+          <a:lstStyle/>
+          <a:p>
+            <a:pPr algn="l">
+              <a:lnSpc>
+                <a:spcPts val="1702"/>
+              </a:lnSpc>
+            </a:pPr>
+            <a:r>
+              <a:rPr sz="1309" b="0" i="0">
+                <a:solidFill>
+                  <a:srgbClr val="C8A15A"/>
+                </a:solidFill>
+                <a:latin typeface="Calibri"/>
+              </a:rPr>
+              <a:t>Per site per month</a:t>
+            </a:r>
+          </a:p>
+        </p:txBody>
+      </p:sp>
+      <p:sp>
+        <p:nvSpPr>
+          <p:cNvPr id="41" name="TextBox 40"/>
+          <p:cNvSpPr txBox="1"/>
+          <p:nvPr/>
+        </p:nvSpPr>
+        <p:spPr>
+          <a:xfrm>
+            <a:off x="9638506" y="3655516"/>
+            <a:ext cx="1562894" cy="132060"/>
+          </a:xfrm>
+          <a:prstGeom prst="rect">
+            <a:avLst/>
+          </a:prstGeom>
+          <a:noFill/>
+        </p:spPr>
+        <p:txBody>
+          <a:bodyPr wrap="none" lIns="0" rIns="0" tIns="0" bIns="0" anchor="t">
+            <a:spAutoFit/>
+          </a:bodyPr>
+          <a:lstStyle/>
+          <a:p>
+            <a:pPr algn="l">
+              <a:lnSpc>
+                <a:spcPts val="1008"/>
+              </a:lnSpc>
+            </a:pPr>
+            <a:r>
+              <a:rPr sz="776" b="0" i="0">
+                <a:solidFill>
+                  <a:srgbClr val="F4EEE1">
+                    <a:alpha val="62000"/>
+                  </a:srgbClr>
+                </a:solidFill>
+                <a:latin typeface="Calibri"/>
+              </a:rPr>
+              <a:t>pricing hypothesis: ~$49</a:t>
+            </a:r>
+          </a:p>
+        </p:txBody>
+      </p:sp>
+      <p:sp>
+        <p:nvSpPr>
+          <p:cNvPr id="42" name="TextBox 41"/>
+          <p:cNvSpPr txBox="1"/>
+          <p:nvPr/>
+        </p:nvSpPr>
+        <p:spPr>
+          <a:xfrm>
+            <a:off x="812800" y="4016177"/>
+            <a:ext cx="2915841" cy="241300"/>
+          </a:xfrm>
+          <a:prstGeom prst="rect">
+            <a:avLst/>
+          </a:prstGeom>
+          <a:noFill/>
+        </p:spPr>
+        <p:txBody>
+          <a:bodyPr wrap="none" lIns="0" rIns="0" tIns="0" bIns="0" anchor="t">
+            <a:spAutoFit/>
+          </a:bodyPr>
+          <a:lstStyle/>
+          <a:p>
+            <a:pPr algn="l">
+              <a:lnSpc>
+                <a:spcPts val="1954"/>
+              </a:lnSpc>
+            </a:pPr>
+            <a:r>
+              <a:rPr sz="1441" b="0" i="0">
+                <a:solidFill>
+                  <a:srgbClr val="E9DCBC"/>
+                </a:solidFill>
+                <a:latin typeface="Georgia"/>
+              </a:rPr>
+              <a:t>Cities and city planners</a:t>
+            </a:r>
+          </a:p>
+        </p:txBody>
+      </p:sp>
+      <p:sp>
+        <p:nvSpPr>
+          <p:cNvPr id="43" name="TextBox 42"/>
+          <p:cNvSpPr txBox="1"/>
+          <p:nvPr/>
+        </p:nvSpPr>
+        <p:spPr>
+          <a:xfrm>
+            <a:off x="812800" y="4291112"/>
+            <a:ext cx="2992041" cy="132060"/>
+          </a:xfrm>
+          <a:prstGeom prst="rect">
+            <a:avLst/>
+          </a:prstGeom>
+          <a:noFill/>
+        </p:spPr>
+        <p:txBody>
+          <a:bodyPr wrap="none" lIns="0" rIns="0" tIns="0" bIns="0" anchor="t">
+            <a:spAutoFit/>
+          </a:bodyPr>
+          <a:lstStyle/>
+          <a:p>
+            <a:pPr algn="l">
+              <a:lnSpc>
+                <a:spcPts val="1008"/>
+              </a:lnSpc>
+            </a:pPr>
+            <a:r>
+              <a:rPr sz="776" b="0" i="0">
+                <a:solidFill>
+                  <a:srgbClr val="F4EEE1">
+                    <a:alpha val="62000"/>
+                  </a:srgbClr>
+                </a:solidFill>
+                <a:latin typeface="Calibri"/>
+              </a:rPr>
+              <a:t>B2G planning analytics</a:t>
+            </a:r>
+          </a:p>
+        </p:txBody>
+      </p:sp>
+      <p:sp>
+        <p:nvSpPr>
+          <p:cNvPr id="44" name="TextBox 43"/>
+          <p:cNvSpPr txBox="1"/>
+          <p:nvPr/>
+        </p:nvSpPr>
+        <p:spPr>
+          <a:xfrm>
+            <a:off x="3982641" y="4006652"/>
+            <a:ext cx="5642408" cy="518716"/>
+          </a:xfrm>
+          <a:prstGeom prst="rect">
+            <a:avLst/>
+          </a:prstGeom>
+          <a:noFill/>
+        </p:spPr>
+        <p:txBody>
+          <a:bodyPr wrap="square" lIns="0" rIns="0" tIns="0" bIns="0" anchor="t">
+            <a:spAutoFit/>
+          </a:bodyPr>
+          <a:lstStyle/>
+          <a:p>
+            <a:pPr algn="l">
+              <a:lnSpc>
+                <a:spcPts val="1702"/>
+              </a:lnSpc>
+            </a:pPr>
+            <a:r>
+              <a:rPr sz="1309" b="0" i="0">
+                <a:solidFill>
+                  <a:srgbClr val="F4EEE1"/>
+                </a:solidFill>
+                <a:latin typeface="Calibri"/>
+              </a:rPr>
+              <a:t>Where to plant trees or add shade, from the same engine</a:t>
+            </a:r>
+          </a:p>
+        </p:txBody>
+      </p:sp>
+      <p:sp>
+        <p:nvSpPr>
+          <p:cNvPr id="45" name="TextBox 44"/>
+          <p:cNvSpPr txBox="1"/>
+          <p:nvPr/>
+        </p:nvSpPr>
+        <p:spPr>
+          <a:xfrm>
+            <a:off x="9638506" y="4016177"/>
+            <a:ext cx="1486694" cy="209550"/>
+          </a:xfrm>
+          <a:prstGeom prst="rect">
+            <a:avLst/>
+          </a:prstGeom>
+          <a:noFill/>
+        </p:spPr>
+        <p:txBody>
+          <a:bodyPr wrap="none" lIns="0" rIns="0" tIns="0" bIns="0" anchor="t">
+            <a:spAutoFit/>
+          </a:bodyPr>
+          <a:lstStyle/>
+          <a:p>
+            <a:pPr algn="l">
+              <a:lnSpc>
+                <a:spcPts val="1702"/>
+              </a:lnSpc>
+            </a:pPr>
+            <a:r>
+              <a:rPr sz="1309" b="0" i="0">
+                <a:solidFill>
+                  <a:srgbClr val="C8A15A"/>
+                </a:solidFill>
+                <a:latin typeface="Calibri"/>
+              </a:rPr>
+              <a:t>City licence</a:t>
+            </a:r>
+          </a:p>
+        </p:txBody>
+      </p:sp>
+      <p:sp>
+        <p:nvSpPr>
+          <p:cNvPr id="46" name="TextBox 45"/>
+          <p:cNvSpPr txBox="1"/>
+          <p:nvPr/>
+        </p:nvSpPr>
+        <p:spPr>
+          <a:xfrm>
+            <a:off x="9638506" y="4258072"/>
+            <a:ext cx="1609781" cy="264120"/>
+          </a:xfrm>
+          <a:prstGeom prst="rect">
+            <a:avLst/>
+          </a:prstGeom>
+          <a:noFill/>
+        </p:spPr>
+        <p:txBody>
+          <a:bodyPr wrap="square" lIns="0" rIns="0" tIns="0" bIns="0" anchor="t">
+            <a:spAutoFit/>
+          </a:bodyPr>
+          <a:lstStyle/>
+          <a:p>
+            <a:pPr algn="l">
+              <a:lnSpc>
+                <a:spcPts val="1008"/>
+              </a:lnSpc>
+            </a:pPr>
+            <a:r>
+              <a:rPr sz="776" b="0" i="0">
+                <a:solidFill>
+                  <a:srgbClr val="F4EEE1">
+                    <a:alpha val="62000"/>
+                  </a:srgbClr>
+                </a:solidFill>
+                <a:latin typeface="Calibri"/>
+              </a:rPr>
+              <a:t>pricing hypothesis: ~$15,000 per year</a:t>
+            </a:r>
+          </a:p>
+        </p:txBody>
+      </p:sp>
+      <p:sp>
+        <p:nvSpPr>
+          <p:cNvPr id="47" name="TextBox 46"/>
+          <p:cNvSpPr txBox="1"/>
+          <p:nvPr/>
+        </p:nvSpPr>
+        <p:spPr>
+          <a:xfrm>
+            <a:off x="812800" y="4741267"/>
+            <a:ext cx="3081802" cy="518120"/>
+          </a:xfrm>
+          <a:prstGeom prst="rect">
+            <a:avLst/>
+          </a:prstGeom>
+          <a:noFill/>
+        </p:spPr>
+        <p:txBody>
+          <a:bodyPr wrap="square" lIns="0" rIns="0" tIns="0" bIns="0" anchor="t">
+            <a:spAutoFit/>
+          </a:bodyPr>
+          <a:lstStyle/>
+          <a:p>
+            <a:pPr algn="l">
+              <a:lnSpc>
+                <a:spcPts val="1954"/>
+              </a:lnSpc>
+            </a:pPr>
+            <a:r>
+              <a:rPr sz="1441" b="0" i="0">
+                <a:solidFill>
+                  <a:srgbClr val="E9DCBC"/>
+                </a:solidFill>
+                <a:latin typeface="Georgia"/>
+              </a:rPr>
+              <a:t>Schools, elderly care, events, real estate</a:t>
+            </a:r>
+          </a:p>
+        </p:txBody>
+      </p:sp>
+      <p:sp>
+        <p:nvSpPr>
+          <p:cNvPr id="48" name="TextBox 47"/>
+          <p:cNvSpPr txBox="1"/>
+          <p:nvPr/>
+        </p:nvSpPr>
+        <p:spPr>
+          <a:xfrm>
+            <a:off x="3982641" y="4741267"/>
+            <a:ext cx="5642408" cy="518120"/>
+          </a:xfrm>
+          <a:prstGeom prst="rect">
+            <a:avLst/>
+          </a:prstGeom>
+          <a:noFill/>
+        </p:spPr>
+        <p:txBody>
+          <a:bodyPr wrap="square" lIns="0" rIns="0" tIns="0" bIns="0" anchor="t">
+            <a:spAutoFit/>
+          </a:bodyPr>
+          <a:lstStyle/>
+          <a:p>
+            <a:pPr algn="l">
+              <a:lnSpc>
+                <a:spcPts val="1702"/>
+              </a:lnSpc>
+            </a:pPr>
+            <a:r>
+              <a:rPr sz="1309" b="0" i="0">
+                <a:solidFill>
+                  <a:srgbClr val="F4EEE1"/>
+                </a:solidFill>
+                <a:latin typeface="Calibri"/>
+              </a:rPr>
+              <a:t>Shaded routes and outdoor-time planning; shade and sun reports for sites and venues</a:t>
+            </a:r>
+          </a:p>
+        </p:txBody>
+      </p:sp>
+      <p:sp>
+        <p:nvSpPr>
+          <p:cNvPr id="49" name="TextBox 48"/>
+          <p:cNvSpPr txBox="1"/>
+          <p:nvPr/>
+        </p:nvSpPr>
+        <p:spPr>
+          <a:xfrm>
+            <a:off x="9638506" y="4741267"/>
+            <a:ext cx="1609781" cy="518120"/>
+          </a:xfrm>
+          <a:prstGeom prst="rect">
+            <a:avLst/>
+          </a:prstGeom>
+          <a:noFill/>
+        </p:spPr>
+        <p:txBody>
+          <a:bodyPr wrap="square" lIns="0" rIns="0" tIns="0" bIns="0" anchor="t">
+            <a:spAutoFit/>
+          </a:bodyPr>
+          <a:lstStyle/>
+          <a:p>
+            <a:pPr algn="l">
+              <a:lnSpc>
+                <a:spcPts val="1702"/>
+              </a:lnSpc>
+            </a:pPr>
+            <a:r>
+              <a:rPr sz="1309" b="0" i="0">
+                <a:solidFill>
+                  <a:srgbClr val="C8A15A"/>
+                </a:solidFill>
+                <a:latin typeface="Calibri"/>
+              </a:rPr>
+              <a:t>Per site subscription</a:t>
             </a:r>
           </a:p>
         </p:txBody>
@@ -11816,6 +11822,205 @@
       <p:sp>
         <p:nvSpPr>
           <p:cNvPr id="50" name="TextBox 49"/>
+          <p:cNvSpPr txBox="1"/>
+          <p:nvPr/>
+        </p:nvSpPr>
+        <p:spPr>
+          <a:xfrm>
+            <a:off x="812800" y="5475288"/>
+            <a:ext cx="3081802" cy="609501"/>
+          </a:xfrm>
+          <a:prstGeom prst="rect">
+            <a:avLst/>
+          </a:prstGeom>
+          <a:noFill/>
+        </p:spPr>
+        <p:txBody>
+          <a:bodyPr wrap="square" lIns="0" rIns="0" tIns="0" bIns="0" anchor="t">
+            <a:spAutoFit/>
+          </a:bodyPr>
+          <a:lstStyle/>
+          <a:p>
+            <a:pPr algn="l">
+              <a:lnSpc>
+                <a:spcPts val="1954"/>
+              </a:lnSpc>
+            </a:pPr>
+            <a:r>
+              <a:rPr sz="1441" b="0" i="0">
+                <a:solidFill>
+                  <a:srgbClr val="E9DCBC"/>
+                </a:solidFill>
+                <a:latin typeface="Georgia"/>
+              </a:rPr>
+              <a:t>Corporate well-being and insurers</a:t>
+            </a:r>
+          </a:p>
+        </p:txBody>
+      </p:sp>
+      <p:sp>
+        <p:nvSpPr>
+          <p:cNvPr id="51" name="TextBox 50"/>
+          <p:cNvSpPr txBox="1"/>
+          <p:nvPr/>
+        </p:nvSpPr>
+        <p:spPr>
+          <a:xfrm>
+            <a:off x="3982641" y="5475288"/>
+            <a:ext cx="5642408" cy="609501"/>
+          </a:xfrm>
+          <a:prstGeom prst="rect">
+            <a:avLst/>
+          </a:prstGeom>
+          <a:noFill/>
+        </p:spPr>
+        <p:txBody>
+          <a:bodyPr wrap="square" lIns="0" rIns="0" tIns="0" bIns="0" anchor="t">
+            <a:spAutoFit/>
+          </a:bodyPr>
+          <a:lstStyle/>
+          <a:p>
+            <a:pPr algn="l">
+              <a:lnSpc>
+                <a:spcPts val="1702"/>
+              </a:lnSpc>
+            </a:pPr>
+            <a:r>
+              <a:rPr sz="1309" b="0" i="0">
+                <a:solidFill>
+                  <a:srgbClr val="F4EEE1"/>
+                </a:solidFill>
+                <a:latin typeface="Calibri"/>
+              </a:rPr>
+              <a:t>Daylight-walk programmes for staff</a:t>
+            </a:r>
+          </a:p>
+        </p:txBody>
+      </p:sp>
+      <p:sp>
+        <p:nvSpPr>
+          <p:cNvPr id="52" name="TextBox 51"/>
+          <p:cNvSpPr txBox="1"/>
+          <p:nvPr/>
+        </p:nvSpPr>
+        <p:spPr>
+          <a:xfrm>
+            <a:off x="9638506" y="5484812"/>
+            <a:ext cx="1531295" cy="432395"/>
+          </a:xfrm>
+          <a:prstGeom prst="rect">
+            <a:avLst/>
+          </a:prstGeom>
+          <a:noFill/>
+        </p:spPr>
+        <p:txBody>
+          <a:bodyPr wrap="square" lIns="0" rIns="0" tIns="0" bIns="0" anchor="t">
+            <a:spAutoFit/>
+          </a:bodyPr>
+          <a:lstStyle/>
+          <a:p>
+            <a:pPr algn="l">
+              <a:lnSpc>
+                <a:spcPts val="1702"/>
+              </a:lnSpc>
+            </a:pPr>
+            <a:r>
+              <a:rPr sz="1309" b="0" i="0">
+                <a:solidFill>
+                  <a:srgbClr val="C8A15A"/>
+                </a:solidFill>
+                <a:latin typeface="Calibri"/>
+              </a:rPr>
+              <a:t>Per employee per year</a:t>
+            </a:r>
+          </a:p>
+        </p:txBody>
+      </p:sp>
+      <p:sp>
+        <p:nvSpPr>
+          <p:cNvPr id="53" name="TextBox 52"/>
+          <p:cNvSpPr txBox="1"/>
+          <p:nvPr/>
+        </p:nvSpPr>
+        <p:spPr>
+          <a:xfrm>
+            <a:off x="9638506" y="5949553"/>
+            <a:ext cx="1562894" cy="132060"/>
+          </a:xfrm>
+          <a:prstGeom prst="rect">
+            <a:avLst/>
+          </a:prstGeom>
+          <a:noFill/>
+        </p:spPr>
+        <p:txBody>
+          <a:bodyPr wrap="none" lIns="0" rIns="0" tIns="0" bIns="0" anchor="t">
+            <a:spAutoFit/>
+          </a:bodyPr>
+          <a:lstStyle/>
+          <a:p>
+            <a:pPr algn="l">
+              <a:lnSpc>
+                <a:spcPts val="1008"/>
+              </a:lnSpc>
+            </a:pPr>
+            <a:r>
+              <a:rPr sz="776" b="0" i="0">
+                <a:solidFill>
+                  <a:srgbClr val="F4EEE1">
+                    <a:alpha val="62000"/>
+                  </a:srgbClr>
+                </a:solidFill>
+                <a:latin typeface="Calibri"/>
+              </a:rPr>
+              <a:t>pricing hypothesis: ~$12</a:t>
+            </a:r>
+          </a:p>
+        </p:txBody>
+      </p:sp>
+      <p:sp>
+        <p:nvSpPr>
+          <p:cNvPr id="54" name="TextBox 53"/>
+          <p:cNvSpPr txBox="1"/>
+          <p:nvPr/>
+        </p:nvSpPr>
+        <p:spPr>
+          <a:xfrm>
+            <a:off x="812800" y="6310213"/>
+            <a:ext cx="10566400" cy="190500"/>
+          </a:xfrm>
+          <a:prstGeom prst="rect">
+            <a:avLst/>
+          </a:prstGeom>
+          <a:noFill/>
+        </p:spPr>
+        <p:txBody>
+          <a:bodyPr wrap="none" lIns="0" rIns="0" tIns="0" bIns="0" anchor="t">
+            <a:spAutoFit/>
+          </a:bodyPr>
+          <a:lstStyle/>
+          <a:p>
+            <a:pPr algn="l">
+              <a:lnSpc>
+                <a:spcPts val="1455"/>
+              </a:lnSpc>
+            </a:pPr>
+            <a:r>
+              <a:rPr sz="969" b="0" i="0">
+                <a:solidFill>
+                  <a:srgbClr val="F4EEE1">
+                    <a:alpha val="62000"/>
+                  </a:srgbClr>
+                </a:solidFill>
+                <a:latin typeface="Calibri"/>
+              </a:rPr>
+              <a:t>Prices shown are our pricing hypotheses, not validated quotes. Consumer premium: ~$2.99 per month, no ads.</a:t>
+            </a:r>
+          </a:p>
+        </p:txBody>
+      </p:sp>
+      <p:sp>
+        <p:nvSpPr>
+          <p:cNvPr id="55" name="TextBox 54"/>
           <p:cNvSpPr txBox="1"/>
           <p:nvPr/>
         </p:nvSpPr>
@@ -11854,7 +12059,7 @@
       </p:sp>
       <p:sp>
         <p:nvSpPr>
-          <p:cNvPr id="51" name="TextBox 50"/>
+          <p:cNvPr id="56" name="TextBox 55"/>
           <p:cNvSpPr txBox="1"/>
           <p:nvPr/>
         </p:nvSpPr>
@@ -13934,7 +14139,7 @@
                 </a:solidFill>
                 <a:latin typeface="Georgia"/>
               </a:rPr>
-              <a:t>[TEAM TO FILL]</a:t>
+              <a:t>$6.93</a:t>
             </a:r>
           </a:p>
         </p:txBody>
@@ -13948,7 +14153,7 @@
         <p:spPr>
           <a:xfrm>
             <a:off x="1073150" y="2773362"/>
-            <a:ext cx="2066798" cy="666750"/>
+            <a:ext cx="2066798" cy="1333500"/>
           </a:xfrm>
           <a:prstGeom prst="rect">
             <a:avLst/>
@@ -13973,7 +14178,7 @@
                 </a:solidFill>
                 <a:latin typeface="Calibri"/>
               </a:rPr>
-              <a:t>Contabo plan price. The VM is shared with other apps, so Zill’s share is a fraction.</a:t>
+              <a:t>per month: Contabo VPS, 4 vCPU, 8 GB. The VM is shared with other apps, so Zill’s share is a fraction. Total fixed cost about $17 per month with the agent.</a:t>
             </a:r>
           </a:p>
         </p:txBody>
@@ -14285,7 +14490,7 @@
                 </a:solidFill>
                 <a:latin typeface="Georgia"/>
               </a:rPr>
-              <a:t>[TEAM TO FILL]</a:t>
+              <a:t>≈ $0.002</a:t>
             </a:r>
           </a:p>
         </p:txBody>
@@ -14299,7 +14504,7 @@
         <p:spPr>
           <a:xfrm>
             <a:off x="9112250" y="2773362"/>
-            <a:ext cx="2066798" cy="666750"/>
+            <a:ext cx="2066798" cy="889000"/>
           </a:xfrm>
           <a:prstGeom prst="rect">
             <a:avLst/>
@@ -14324,7 +14529,7 @@
                 </a:solidFill>
                 <a:latin typeface="Calibri"/>
               </a:rPr>
-              <a:t>Server share is plan price × 0.0003, assuming 20 requests per visit.</a:t>
+              <a:t>of server per 1,000 users: plan price × 0.0003, assuming 20 requests per visit.</a:t>
             </a:r>
           </a:p>
         </p:txBody>
@@ -14365,7 +14570,7 @@
                 </a:solidFill>
                 <a:latin typeface="Calibri"/>
               </a:rPr>
-              <a:t>Source: docs/COSTS.md. Token counts use characters ÷ 4 on the scripted planner, so output tokens are a lower bound. Bake timings were measured on a dev laptop, not the VM. Per-token API prices and Open-Meteo commercial pricing are [TEAM TO FILL].</a:t>
+              <a:t>Source: docs/COSTS.md. Token counts use characters ÷ 4 on the scripted planner, so output tokens are a lower bound. Bake timings were measured on a dev laptop, not the VM. Per-token API prices are not used (flat subscription). Open-Meteo’s free tier is non-commercial, so a paid plan is needed before B2B revenue.</a:t>
             </a:r>
           </a:p>
         </p:txBody>
@@ -17120,27 +17325,7 @@
                 </a:solidFill>
                 <a:latin typeface="Calibri"/>
               </a:rPr>
-              <a:t>One API worker saturates near 26 requests per second on this machine. The live run (capped at 20 concurrent users, 48 s) did not reach its limit, and its latency includes the network round trip. VM CPU count: </a:t>
-            </a:r>
-            <a:r>
-              <a:rPr sz="921" b="0" i="0">
-                <a:solidFill>
-                  <a:srgbClr val="D07A35"/>
-                </a:solidFill>
-                <a:latin typeface="Calibri"/>
-              </a:rPr>
-              <a:t>[TEAM TO FILL]</a:t>
-            </a:r>
-            <a:r>
-              <a:rPr sz="921" b="0" i="0">
-                <a:solidFill>
-                  <a:srgbClr val="F4EEE1">
-                    <a:alpha val="62000"/>
-                  </a:srgbClr>
-                </a:solidFill>
-                <a:latin typeface="Calibri"/>
-              </a:rPr>
-              <a:t>.</a:t>
+              <a:t>One API worker saturates near 26 requests per second on this machine. The live run (capped at 20 concurrent users, 48 s) did not reach its limit, and its latency includes the network round trip. VM: 4 vCPU, 8 GB.</a:t>
             </a:r>
           </a:p>
         </p:txBody>

</xml_diff>